<commit_message>
Entrega final do banner
</commit_message>
<xml_diff>
--- a/Documentos/Banner_FECAP_CCOMP5_AbraceAI.pptx
+++ b/Documentos/Banner_FECAP_CCOMP5_AbraceAI.pptx
@@ -273,7 +273,7 @@
       </p15:sldGuideLst>
     </p:ext>
     <p:ext uri="GoogleSlidesCustomDataVersion2">
-      <go:slidesCustomData xmlns="" xmlns:mc="http://schemas.openxmlformats.org/markup-compatibility/2006" xmlns:mv="urn:schemas-microsoft-com:mac:vml" xmlns:c="http://schemas.openxmlformats.org/drawingml/2006/chart" xmlns:dgm="http://schemas.openxmlformats.org/drawingml/2006/diagram" xmlns:o="urn:schemas-microsoft-com:office:office" xmlns:v="urn:schemas-microsoft-com:vml" xmlns:pvml="urn:schemas-microsoft-com:office:powerpoint" xmlns:com="http://schemas.openxmlformats.org/drawingml/2006/compatibility" xmlns:p14="http://schemas.microsoft.com/office/powerpoint/2010/main" xmlns:p15="http://schemas.microsoft.com/office/powerpoint/2012/main" xmlns:ahyp="http://schemas.microsoft.com/office/drawing/2018/hyperlinkcolor" xmlns:go="http://customooxmlschemas.google.com/" r:id="rId13" roundtripDataSignature="AMtx7mi+9yr4mDS8zg5+kfXTqvtBuST67g=="/>
+      <go:slidesCustomData xmlns:go="http://customooxmlschemas.google.com/" xmlns:ahyp="http://schemas.microsoft.com/office/drawing/2018/hyperlinkcolor" xmlns:p15="http://schemas.microsoft.com/office/powerpoint/2012/main" xmlns:p14="http://schemas.microsoft.com/office/powerpoint/2010/main" xmlns:com="http://schemas.openxmlformats.org/drawingml/2006/compatibility" xmlns:pvml="urn:schemas-microsoft-com:office:powerpoint" xmlns:v="urn:schemas-microsoft-com:vml" xmlns:o="urn:schemas-microsoft-com:office:office" xmlns:dgm="http://schemas.openxmlformats.org/drawingml/2006/diagram" xmlns:c="http://schemas.openxmlformats.org/drawingml/2006/chart" xmlns:mv="urn:schemas-microsoft-com:mac:vml" xmlns:mc="http://schemas.openxmlformats.org/markup-compatibility/2006" xmlns="" r:id="rId13" roundtripDataSignature="AMtx7mi+9yr4mDS8zg5+kfXTqvtBuST67g=="/>
     </p:ext>
   </p:extLst>
 </p:presentation>
@@ -13176,7 +13176,7 @@
                 <a:cs typeface="Open Sans"/>
                 <a:sym typeface="Open Sans"/>
               </a:rPr>
-              <a:t>Contagem manual de itens </a:t>
+              <a:t>Contagem manual de itens: </a:t>
             </a:r>
             <a:r>
               <a:rPr lang="pt-BR" sz="3430" noProof="0" dirty="0">
@@ -13188,7 +13188,7 @@
                 <a:cs typeface="Open Sans"/>
                 <a:sym typeface="Open Sans"/>
               </a:rPr>
-              <a:t>— seja das doações ou do estoque — é um processo lento, repetitivo e altamente sujeito a erros humanos.</a:t>
+              <a:t> seja das doações ou do estoque, é um processo lento, repetitivo e altamente sujeito a erros humanos, não garantindo total assertividade no processo.</a:t>
             </a:r>
           </a:p>
           <a:p>
@@ -13542,7 +13542,7 @@
                 <a:cs typeface="Open Sans"/>
                 <a:sym typeface="Open Sans"/>
               </a:rPr>
-              <a:t> qualquer usuário — aluno, mentor ou professores — pode realizar capturas e acompanhar os dados em tempo real por dashboards online.</a:t>
+              <a:t> qualquer usuário (aluno, mentor ou professores) pode realizar capturas e acompanhar os dados em tempo real por dashboards online.</a:t>
             </a:r>
           </a:p>
           <a:p>
@@ -13783,7 +13783,7 @@
                 <a:cs typeface="Open Sans"/>
                 <a:sym typeface="Open Sans"/>
               </a:rPr>
-              <a:t>o modelo atingiu mAP50 ≈ 0,75 ao longo do treinamento — valor considerado bom em detecção por visão computacional —, confirmando assertividade na identificação e contagem automática de itens e equiparando a confiabilidade da triagem manual.</a:t>
+              <a:t>o modelo atingiu mAP@50 ≈ 0,75 ao longo do treinamento, um valor considerado bom em detecção por visão computacional, confirmando assertividade na identificação e contagem automática de itens e equiparando a confiabilidade da triagem manual.</a:t>
             </a:r>
             <a:endParaRPr lang="pt-BR" noProof="0" dirty="0"/>
           </a:p>
@@ -13889,7 +13889,46 @@
                 <a:cs typeface="Open Sans"/>
                 <a:sym typeface="Open Sans"/>
               </a:rPr>
-              <a:t>o sistema opera com webcam comum via interface web, eliminando a necessidade de hardware especializado ou dispositivos caros, o que poderia inviabilizar a solução para </a:t>
+              <a:t>o sistema opera com webcam comum via web, eliminando a necessidade de hardwares especializados, como GPU</a:t>
+            </a:r>
+            <a:r>
+              <a:rPr lang="pt-BR" sz="3430" dirty="0">
+                <a:latin typeface="Open Sans"/>
+                <a:ea typeface="Open Sans"/>
+                <a:cs typeface="Open Sans"/>
+                <a:sym typeface="Open Sans"/>
+              </a:rPr>
+              <a:t>’</a:t>
+            </a:r>
+            <a:r>
+              <a:rPr lang="pt-BR" sz="3430" dirty="0" err="1">
+                <a:latin typeface="Open Sans"/>
+                <a:ea typeface="Open Sans"/>
+                <a:cs typeface="Open Sans"/>
+                <a:sym typeface="Open Sans"/>
+              </a:rPr>
+              <a:t>s</a:t>
+            </a:r>
+            <a:r>
+              <a:rPr lang="pt-BR" sz="3430" dirty="0">
+                <a:latin typeface="Open Sans"/>
+                <a:ea typeface="Open Sans"/>
+                <a:cs typeface="Open Sans"/>
+                <a:sym typeface="Open Sans"/>
+              </a:rPr>
+              <a:t> e câmeras de alta resolução</a:t>
+            </a:r>
+            <a:r>
+              <a:rPr lang="pt-BR" sz="3430" noProof="0" dirty="0">
+                <a:solidFill>
+                  <a:srgbClr val="000000"/>
+                </a:solidFill>
+                <a:latin typeface="Open Sans"/>
+                <a:ea typeface="Open Sans"/>
+                <a:cs typeface="Open Sans"/>
+                <a:sym typeface="Open Sans"/>
+              </a:rPr>
+              <a:t>, barateando a solução, o que, caso contrário, poderia inviabilizar a solução para </a:t>
             </a:r>
             <a:r>
               <a:rPr lang="pt-BR" sz="3430" noProof="0" dirty="0" err="1">
@@ -13974,7 +14013,7 @@
                 <a:cs typeface="Open Sans"/>
                 <a:sym typeface="Open Sans"/>
               </a:rPr>
-              <a:t>o modelo foi treinado e validado para reconhecer os principais alimentos de cesta básica — os itens mais frequentemente doados em campanhas solidárias —, garantindo que o </a:t>
+              <a:t>o modelo foi treinado e validado para reconhecer os principais alimentos de cesta básica (os itens mais frequentemente doados em campanhas solidárias), garantindo que o </a:t>
             </a:r>
             <a:r>
               <a:rPr lang="pt-BR" sz="3430" noProof="0" dirty="0" err="1">
@@ -14099,7 +14138,7 @@
         </p:blipFill>
         <p:spPr bwMode="auto">
           <a:xfrm>
-            <a:off x="7426843" y="32421131"/>
+            <a:off x="7194710" y="32471756"/>
             <a:ext cx="3299833" cy="1402340"/>
           </a:xfrm>
           <a:prstGeom prst="rect">
@@ -14146,7 +14185,7 @@
         </p:blipFill>
         <p:spPr bwMode="auto">
           <a:xfrm>
-            <a:off x="4582620" y="32519786"/>
+            <a:off x="4830792" y="32570133"/>
             <a:ext cx="1154320" cy="1154320"/>
           </a:xfrm>
           <a:prstGeom prst="rect">
@@ -14354,7 +14393,7 @@
         </p:blipFill>
         <p:spPr bwMode="auto">
           <a:xfrm>
-            <a:off x="2113558" y="34678963"/>
+            <a:off x="1961425" y="34729162"/>
             <a:ext cx="3046222" cy="1236007"/>
           </a:xfrm>
           <a:prstGeom prst="rect">
@@ -14401,7 +14440,7 @@
         </p:blipFill>
         <p:spPr bwMode="auto">
           <a:xfrm>
-            <a:off x="6061312" y="34626377"/>
+            <a:off x="5985112" y="34653578"/>
             <a:ext cx="3695253" cy="1234800"/>
           </a:xfrm>
           <a:prstGeom prst="rect">
@@ -14448,7 +14487,7 @@
         </p:blipFill>
         <p:spPr bwMode="auto">
           <a:xfrm>
-            <a:off x="10806244" y="34663205"/>
+            <a:off x="11106543" y="34685934"/>
             <a:ext cx="2736873" cy="1234800"/>
           </a:xfrm>
           <a:prstGeom prst="rect">
@@ -14495,7 +14534,7 @@
         </p:blipFill>
         <p:spPr bwMode="auto">
           <a:xfrm>
-            <a:off x="11733678" y="32456294"/>
+            <a:off x="11704142" y="32528783"/>
             <a:ext cx="2287329" cy="1234800"/>
           </a:xfrm>
           <a:prstGeom prst="rect">
@@ -14542,7 +14581,7 @@
         </p:blipFill>
         <p:spPr bwMode="auto">
           <a:xfrm>
-            <a:off x="7926967" y="36834666"/>
+            <a:off x="7233157" y="36861010"/>
             <a:ext cx="1387620" cy="1234800"/>
           </a:xfrm>
           <a:prstGeom prst="rect">
@@ -14589,7 +14628,7 @@
         </p:blipFill>
         <p:spPr bwMode="auto">
           <a:xfrm>
-            <a:off x="3163236" y="36887771"/>
+            <a:off x="2868037" y="36778337"/>
             <a:ext cx="1234800" cy="1234800"/>
           </a:xfrm>
           <a:prstGeom prst="rect">
@@ -14636,7 +14675,7 @@
         </p:blipFill>
         <p:spPr bwMode="auto">
           <a:xfrm>
-            <a:off x="1478556" y="32306154"/>
+            <a:off x="1358010" y="32305453"/>
             <a:ext cx="2318915" cy="2063914"/>
           </a:xfrm>
           <a:prstGeom prst="rect">
@@ -14669,7 +14708,7 @@
         <p:spPr>
           <a:xfrm>
             <a:off x="15714840" y="31688607"/>
-            <a:ext cx="11904157" cy="6398675"/>
+            <a:ext cx="11904157" cy="6290953"/>
           </a:xfrm>
           <a:prstGeom prst="rect">
             <a:avLst/>
@@ -14685,698 +14724,636 @@
           </a:bodyPr>
           <a:lstStyle/>
           <a:p>
-            <a:pPr marL="0" marR="0" lvl="0" indent="0" algn="just" rtl="0">
+            <a:pPr lvl="0" algn="just">
               <a:lnSpc>
                 <a:spcPct val="140000"/>
               </a:lnSpc>
-              <a:spcBef>
-                <a:spcPts val="0"/>
-              </a:spcBef>
-              <a:spcAft>
-                <a:spcPts val="0"/>
-              </a:spcAft>
-              <a:buNone/>
             </a:pPr>
             <a:r>
-              <a:rPr lang="pt-BR" sz="2800" noProof="0" dirty="0">
-                <a:solidFill>
-                  <a:srgbClr val="000000"/>
-                </a:solidFill>
-                <a:latin typeface="Open Sans"/>
-                <a:ea typeface="Open Sans"/>
-                <a:cs typeface="Open Sans"/>
-                <a:sym typeface="Open Sans"/>
+              <a:rPr lang="pt-BR" sz="2800" dirty="0">
+                <a:solidFill>
+                  <a:schemeClr val="tx1"/>
+                </a:solidFill>
+                <a:latin typeface="Open Sans" panose="020B0606030504020204" pitchFamily="34" charset="0"/>
+                <a:ea typeface="Open Sans" panose="020B0606030504020204" pitchFamily="34" charset="0"/>
+                <a:cs typeface="Open Sans" panose="020B0606030504020204" pitchFamily="34" charset="0"/>
               </a:rPr>
-              <a:t>ELECTRONICS, </a:t>
+              <a:t>ROKHVA, </a:t>
             </a:r>
             <a:r>
-              <a:rPr lang="pt-BR" sz="2800" noProof="0" dirty="0" err="1">
-                <a:solidFill>
-                  <a:srgbClr val="000000"/>
-                </a:solidFill>
-                <a:latin typeface="Open Sans"/>
-                <a:ea typeface="Open Sans"/>
-                <a:cs typeface="Open Sans"/>
-                <a:sym typeface="Open Sans"/>
+              <a:rPr lang="pt-BR" sz="2800" dirty="0" err="1">
+                <a:solidFill>
+                  <a:schemeClr val="tx1"/>
+                </a:solidFill>
+                <a:latin typeface="Open Sans" panose="020B0606030504020204" pitchFamily="34" charset="0"/>
+                <a:ea typeface="Open Sans" panose="020B0606030504020204" pitchFamily="34" charset="0"/>
+                <a:cs typeface="Open Sans" panose="020B0606030504020204" pitchFamily="34" charset="0"/>
               </a:rPr>
-              <a:t>Edje</a:t>
+              <a:t>Shayan</a:t>
             </a:r>
             <a:r>
-              <a:rPr lang="pt-BR" sz="2800" noProof="0" dirty="0">
-                <a:solidFill>
-                  <a:srgbClr val="000000"/>
-                </a:solidFill>
-                <a:latin typeface="Open Sans"/>
-                <a:ea typeface="Open Sans"/>
-                <a:cs typeface="Open Sans"/>
-                <a:sym typeface="Open Sans"/>
+              <a:rPr lang="pt-BR" sz="2800" dirty="0">
+                <a:solidFill>
+                  <a:schemeClr val="tx1"/>
+                </a:solidFill>
+                <a:latin typeface="Open Sans" panose="020B0606030504020204" pitchFamily="34" charset="0"/>
+                <a:ea typeface="Open Sans" panose="020B0606030504020204" pitchFamily="34" charset="0"/>
+                <a:cs typeface="Open Sans" panose="020B0606030504020204" pitchFamily="34" charset="0"/>
+              </a:rPr>
+              <a:t>; TEIMOURPOUR, </a:t>
+            </a:r>
+            <a:r>
+              <a:rPr lang="pt-BR" sz="2800" dirty="0" err="1">
+                <a:solidFill>
+                  <a:schemeClr val="tx1"/>
+                </a:solidFill>
+                <a:latin typeface="Open Sans" panose="020B0606030504020204" pitchFamily="34" charset="0"/>
+                <a:ea typeface="Open Sans" panose="020B0606030504020204" pitchFamily="34" charset="0"/>
+                <a:cs typeface="Open Sans" panose="020B0606030504020204" pitchFamily="34" charset="0"/>
+              </a:rPr>
+              <a:t>Babak</a:t>
+            </a:r>
+            <a:r>
+              <a:rPr lang="pt-BR" sz="2800" dirty="0">
+                <a:solidFill>
+                  <a:schemeClr val="tx1"/>
+                </a:solidFill>
+                <a:latin typeface="Open Sans" panose="020B0606030504020204" pitchFamily="34" charset="0"/>
+                <a:ea typeface="Open Sans" panose="020B0606030504020204" pitchFamily="34" charset="0"/>
+                <a:cs typeface="Open Sans" panose="020B0606030504020204" pitchFamily="34" charset="0"/>
+              </a:rPr>
+              <a:t>; SOLTANI, Amir Hossein. </a:t>
+            </a:r>
+            <a:r>
+              <a:rPr lang="pt-BR" sz="2800" b="1" dirty="0">
+                <a:solidFill>
+                  <a:schemeClr val="tx1"/>
+                </a:solidFill>
+                <a:latin typeface="Open Sans" panose="020B0606030504020204" pitchFamily="34" charset="0"/>
+                <a:ea typeface="Open Sans" panose="020B0606030504020204" pitchFamily="34" charset="0"/>
+                <a:cs typeface="Open Sans" panose="020B0606030504020204" pitchFamily="34" charset="0"/>
+              </a:rPr>
+              <a:t>Computer </a:t>
+            </a:r>
+            <a:r>
+              <a:rPr lang="pt-BR" sz="2800" b="1" dirty="0" err="1">
+                <a:solidFill>
+                  <a:schemeClr val="tx1"/>
+                </a:solidFill>
+                <a:latin typeface="Open Sans" panose="020B0606030504020204" pitchFamily="34" charset="0"/>
+                <a:ea typeface="Open Sans" panose="020B0606030504020204" pitchFamily="34" charset="0"/>
+                <a:cs typeface="Open Sans" panose="020B0606030504020204" pitchFamily="34" charset="0"/>
+              </a:rPr>
+              <a:t>vision</a:t>
+            </a:r>
+            <a:r>
+              <a:rPr lang="pt-BR" sz="2800" b="1" dirty="0">
+                <a:solidFill>
+                  <a:schemeClr val="tx1"/>
+                </a:solidFill>
+                <a:latin typeface="Open Sans" panose="020B0606030504020204" pitchFamily="34" charset="0"/>
+                <a:ea typeface="Open Sans" panose="020B0606030504020204" pitchFamily="34" charset="0"/>
+                <a:cs typeface="Open Sans" panose="020B0606030504020204" pitchFamily="34" charset="0"/>
+              </a:rPr>
+              <a:t> in </a:t>
+            </a:r>
+            <a:r>
+              <a:rPr lang="pt-BR" sz="2800" b="1" dirty="0" err="1">
+                <a:solidFill>
+                  <a:schemeClr val="tx1"/>
+                </a:solidFill>
+                <a:latin typeface="Open Sans" panose="020B0606030504020204" pitchFamily="34" charset="0"/>
+                <a:ea typeface="Open Sans" panose="020B0606030504020204" pitchFamily="34" charset="0"/>
+                <a:cs typeface="Open Sans" panose="020B0606030504020204" pitchFamily="34" charset="0"/>
+              </a:rPr>
+              <a:t>the</a:t>
+            </a:r>
+            <a:r>
+              <a:rPr lang="pt-BR" sz="2800" b="1" dirty="0">
+                <a:solidFill>
+                  <a:schemeClr val="tx1"/>
+                </a:solidFill>
+                <a:latin typeface="Open Sans" panose="020B0606030504020204" pitchFamily="34" charset="0"/>
+                <a:ea typeface="Open Sans" panose="020B0606030504020204" pitchFamily="34" charset="0"/>
+                <a:cs typeface="Open Sans" panose="020B0606030504020204" pitchFamily="34" charset="0"/>
+              </a:rPr>
+              <a:t> food </a:t>
+            </a:r>
+            <a:r>
+              <a:rPr lang="pt-BR" sz="2800" b="1" dirty="0" err="1">
+                <a:solidFill>
+                  <a:schemeClr val="tx1"/>
+                </a:solidFill>
+                <a:latin typeface="Open Sans" panose="020B0606030504020204" pitchFamily="34" charset="0"/>
+                <a:ea typeface="Open Sans" panose="020B0606030504020204" pitchFamily="34" charset="0"/>
+                <a:cs typeface="Open Sans" panose="020B0606030504020204" pitchFamily="34" charset="0"/>
+              </a:rPr>
+              <a:t>industry</a:t>
+            </a:r>
+            <a:r>
+              <a:rPr lang="pt-BR" sz="2800" b="1" dirty="0">
+                <a:solidFill>
+                  <a:schemeClr val="tx1"/>
+                </a:solidFill>
+                <a:latin typeface="Open Sans" panose="020B0606030504020204" pitchFamily="34" charset="0"/>
+                <a:ea typeface="Open Sans" panose="020B0606030504020204" pitchFamily="34" charset="0"/>
+                <a:cs typeface="Open Sans" panose="020B0606030504020204" pitchFamily="34" charset="0"/>
+              </a:rPr>
+              <a:t>: </a:t>
+            </a:r>
+            <a:r>
+              <a:rPr lang="pt-BR" sz="2800" b="1" dirty="0" err="1">
+                <a:solidFill>
+                  <a:schemeClr val="tx1"/>
+                </a:solidFill>
+                <a:latin typeface="Open Sans" panose="020B0606030504020204" pitchFamily="34" charset="0"/>
+                <a:ea typeface="Open Sans" panose="020B0606030504020204" pitchFamily="34" charset="0"/>
+                <a:cs typeface="Open Sans" panose="020B0606030504020204" pitchFamily="34" charset="0"/>
+              </a:rPr>
+              <a:t>accurate</a:t>
+            </a:r>
+            <a:r>
+              <a:rPr lang="pt-BR" sz="2800" b="1" dirty="0">
+                <a:solidFill>
+                  <a:schemeClr val="tx1"/>
+                </a:solidFill>
+                <a:latin typeface="Open Sans" panose="020B0606030504020204" pitchFamily="34" charset="0"/>
+                <a:ea typeface="Open Sans" panose="020B0606030504020204" pitchFamily="34" charset="0"/>
+                <a:cs typeface="Open Sans" panose="020B0606030504020204" pitchFamily="34" charset="0"/>
+              </a:rPr>
+              <a:t>, real-time, </a:t>
+            </a:r>
+            <a:r>
+              <a:rPr lang="pt-BR" sz="2800" b="1" dirty="0" err="1">
+                <a:solidFill>
+                  <a:schemeClr val="tx1"/>
+                </a:solidFill>
+                <a:latin typeface="Open Sans" panose="020B0606030504020204" pitchFamily="34" charset="0"/>
+                <a:ea typeface="Open Sans" panose="020B0606030504020204" pitchFamily="34" charset="0"/>
+                <a:cs typeface="Open Sans" panose="020B0606030504020204" pitchFamily="34" charset="0"/>
+              </a:rPr>
+              <a:t>and</a:t>
+            </a:r>
+            <a:r>
+              <a:rPr lang="pt-BR" sz="2800" b="1" dirty="0">
+                <a:solidFill>
+                  <a:schemeClr val="tx1"/>
+                </a:solidFill>
+                <a:latin typeface="Open Sans" panose="020B0606030504020204" pitchFamily="34" charset="0"/>
+                <a:ea typeface="Open Sans" panose="020B0606030504020204" pitchFamily="34" charset="0"/>
+                <a:cs typeface="Open Sans" panose="020B0606030504020204" pitchFamily="34" charset="0"/>
+              </a:rPr>
+              <a:t> </a:t>
+            </a:r>
+            <a:r>
+              <a:rPr lang="pt-BR" sz="2800" b="1" dirty="0" err="1">
+                <a:solidFill>
+                  <a:schemeClr val="tx1"/>
+                </a:solidFill>
+                <a:latin typeface="Open Sans" panose="020B0606030504020204" pitchFamily="34" charset="0"/>
+                <a:ea typeface="Open Sans" panose="020B0606030504020204" pitchFamily="34" charset="0"/>
+                <a:cs typeface="Open Sans" panose="020B0606030504020204" pitchFamily="34" charset="0"/>
+              </a:rPr>
+              <a:t>automatic</a:t>
+            </a:r>
+            <a:r>
+              <a:rPr lang="pt-BR" sz="2800" b="1" dirty="0">
+                <a:solidFill>
+                  <a:schemeClr val="tx1"/>
+                </a:solidFill>
+                <a:latin typeface="Open Sans" panose="020B0606030504020204" pitchFamily="34" charset="0"/>
+                <a:ea typeface="Open Sans" panose="020B0606030504020204" pitchFamily="34" charset="0"/>
+                <a:cs typeface="Open Sans" panose="020B0606030504020204" pitchFamily="34" charset="0"/>
+              </a:rPr>
+              <a:t> food </a:t>
+            </a:r>
+            <a:r>
+              <a:rPr lang="pt-BR" sz="2800" b="1" dirty="0" err="1">
+                <a:solidFill>
+                  <a:schemeClr val="tx1"/>
+                </a:solidFill>
+                <a:latin typeface="Open Sans" panose="020B0606030504020204" pitchFamily="34" charset="0"/>
+                <a:ea typeface="Open Sans" panose="020B0606030504020204" pitchFamily="34" charset="0"/>
+                <a:cs typeface="Open Sans" panose="020B0606030504020204" pitchFamily="34" charset="0"/>
+              </a:rPr>
+              <a:t>recognition</a:t>
+            </a:r>
+            <a:r>
+              <a:rPr lang="pt-BR" sz="2800" b="1" dirty="0">
+                <a:solidFill>
+                  <a:schemeClr val="tx1"/>
+                </a:solidFill>
+                <a:latin typeface="Open Sans" panose="020B0606030504020204" pitchFamily="34" charset="0"/>
+                <a:ea typeface="Open Sans" panose="020B0606030504020204" pitchFamily="34" charset="0"/>
+                <a:cs typeface="Open Sans" panose="020B0606030504020204" pitchFamily="34" charset="0"/>
+              </a:rPr>
+              <a:t> </a:t>
+            </a:r>
+            <a:r>
+              <a:rPr lang="pt-BR" sz="2800" b="1" dirty="0" err="1">
+                <a:solidFill>
+                  <a:schemeClr val="tx1"/>
+                </a:solidFill>
+                <a:latin typeface="Open Sans" panose="020B0606030504020204" pitchFamily="34" charset="0"/>
+                <a:ea typeface="Open Sans" panose="020B0606030504020204" pitchFamily="34" charset="0"/>
+                <a:cs typeface="Open Sans" panose="020B0606030504020204" pitchFamily="34" charset="0"/>
+              </a:rPr>
+              <a:t>with</a:t>
+            </a:r>
+            <a:r>
+              <a:rPr lang="pt-BR" sz="2800" b="1" dirty="0">
+                <a:solidFill>
+                  <a:schemeClr val="tx1"/>
+                </a:solidFill>
+                <a:latin typeface="Open Sans" panose="020B0606030504020204" pitchFamily="34" charset="0"/>
+                <a:ea typeface="Open Sans" panose="020B0606030504020204" pitchFamily="34" charset="0"/>
+                <a:cs typeface="Open Sans" panose="020B0606030504020204" pitchFamily="34" charset="0"/>
+              </a:rPr>
+              <a:t> </a:t>
+            </a:r>
+            <a:r>
+              <a:rPr lang="pt-BR" sz="2800" b="1" dirty="0" err="1">
+                <a:solidFill>
+                  <a:schemeClr val="tx1"/>
+                </a:solidFill>
+                <a:latin typeface="Open Sans" panose="020B0606030504020204" pitchFamily="34" charset="0"/>
+                <a:ea typeface="Open Sans" panose="020B0606030504020204" pitchFamily="34" charset="0"/>
+                <a:cs typeface="Open Sans" panose="020B0606030504020204" pitchFamily="34" charset="0"/>
+              </a:rPr>
+              <a:t>pretrained</a:t>
+            </a:r>
+            <a:r>
+              <a:rPr lang="pt-BR" sz="2800" b="1" dirty="0">
+                <a:solidFill>
+                  <a:schemeClr val="tx1"/>
+                </a:solidFill>
+                <a:latin typeface="Open Sans" panose="020B0606030504020204" pitchFamily="34" charset="0"/>
+                <a:ea typeface="Open Sans" panose="020B0606030504020204" pitchFamily="34" charset="0"/>
+                <a:cs typeface="Open Sans" panose="020B0606030504020204" pitchFamily="34" charset="0"/>
+              </a:rPr>
+              <a:t> MobileNetV2</a:t>
+            </a:r>
+            <a:r>
+              <a:rPr lang="pt-BR" sz="2800" dirty="0">
+                <a:solidFill>
+                  <a:schemeClr val="tx1"/>
+                </a:solidFill>
+                <a:latin typeface="Open Sans" panose="020B0606030504020204" pitchFamily="34" charset="0"/>
+                <a:ea typeface="Open Sans" panose="020B0606030504020204" pitchFamily="34" charset="0"/>
+                <a:cs typeface="Open Sans" panose="020B0606030504020204" pitchFamily="34" charset="0"/>
               </a:rPr>
               <a:t>. </a:t>
             </a:r>
             <a:r>
-              <a:rPr lang="pt-BR" sz="2800" b="1" noProof="0" dirty="0" err="1">
-                <a:solidFill>
-                  <a:srgbClr val="000000"/>
-                </a:solidFill>
-                <a:latin typeface="Open Sans"/>
-                <a:ea typeface="Open Sans"/>
-                <a:cs typeface="Open Sans"/>
-                <a:sym typeface="Open Sans"/>
+              <a:rPr lang="pt-BR" sz="2800" dirty="0" err="1">
+                <a:solidFill>
+                  <a:schemeClr val="tx1"/>
+                </a:solidFill>
+                <a:latin typeface="Open Sans" panose="020B0606030504020204" pitchFamily="34" charset="0"/>
+                <a:ea typeface="Open Sans" panose="020B0606030504020204" pitchFamily="34" charset="0"/>
+                <a:cs typeface="Open Sans" panose="020B0606030504020204" pitchFamily="34" charset="0"/>
               </a:rPr>
-              <a:t>How</a:t>
+              <a:t>arXiv</a:t>
             </a:r>
             <a:r>
-              <a:rPr lang="pt-BR" sz="2800" b="1" noProof="0" dirty="0">
-                <a:solidFill>
-                  <a:srgbClr val="000000"/>
-                </a:solidFill>
-                <a:latin typeface="Open Sans"/>
-                <a:ea typeface="Open Sans"/>
-                <a:cs typeface="Open Sans"/>
-                <a:sym typeface="Open Sans"/>
+              <a:rPr lang="pt-BR" sz="2800" dirty="0">
+                <a:solidFill>
+                  <a:schemeClr val="tx1"/>
+                </a:solidFill>
+                <a:latin typeface="Open Sans" panose="020B0606030504020204" pitchFamily="34" charset="0"/>
+                <a:ea typeface="Open Sans" panose="020B0606030504020204" pitchFamily="34" charset="0"/>
+                <a:cs typeface="Open Sans" panose="020B0606030504020204" pitchFamily="34" charset="0"/>
+              </a:rPr>
+              <a:t>, 2024. arXiv:2405.11621. Disponível em: https://</a:t>
+            </a:r>
+            <a:r>
+              <a:rPr lang="pt-BR" sz="2800" dirty="0" err="1">
+                <a:solidFill>
+                  <a:schemeClr val="tx1"/>
+                </a:solidFill>
+                <a:latin typeface="Open Sans" panose="020B0606030504020204" pitchFamily="34" charset="0"/>
+                <a:ea typeface="Open Sans" panose="020B0606030504020204" pitchFamily="34" charset="0"/>
+                <a:cs typeface="Open Sans" panose="020B0606030504020204" pitchFamily="34" charset="0"/>
+              </a:rPr>
+              <a:t>arxiv.org</a:t>
+            </a:r>
+            <a:r>
+              <a:rPr lang="pt-BR" sz="2800" dirty="0">
+                <a:solidFill>
+                  <a:schemeClr val="tx1"/>
+                </a:solidFill>
+                <a:latin typeface="Open Sans" panose="020B0606030504020204" pitchFamily="34" charset="0"/>
+                <a:ea typeface="Open Sans" panose="020B0606030504020204" pitchFamily="34" charset="0"/>
+                <a:cs typeface="Open Sans" panose="020B0606030504020204" pitchFamily="34" charset="0"/>
+              </a:rPr>
+              <a:t>/</a:t>
+            </a:r>
+            <a:r>
+              <a:rPr lang="pt-BR" sz="2800" dirty="0" err="1">
+                <a:solidFill>
+                  <a:schemeClr val="tx1"/>
+                </a:solidFill>
+                <a:latin typeface="Open Sans" panose="020B0606030504020204" pitchFamily="34" charset="0"/>
+                <a:ea typeface="Open Sans" panose="020B0606030504020204" pitchFamily="34" charset="0"/>
+                <a:cs typeface="Open Sans" panose="020B0606030504020204" pitchFamily="34" charset="0"/>
+              </a:rPr>
+              <a:t>abs</a:t>
+            </a:r>
+            <a:r>
+              <a:rPr lang="pt-BR" sz="2800" dirty="0">
+                <a:solidFill>
+                  <a:schemeClr val="tx1"/>
+                </a:solidFill>
+                <a:latin typeface="Open Sans" panose="020B0606030504020204" pitchFamily="34" charset="0"/>
+                <a:ea typeface="Open Sans" panose="020B0606030504020204" pitchFamily="34" charset="0"/>
+                <a:cs typeface="Open Sans" panose="020B0606030504020204" pitchFamily="34" charset="0"/>
+              </a:rPr>
+              <a:t>/2405.11621. Acesso em: 16 fev. 2026.</a:t>
+            </a:r>
+          </a:p>
+          <a:p>
+            <a:pPr lvl="0" algn="just">
+              <a:lnSpc>
+                <a:spcPct val="140000"/>
+              </a:lnSpc>
+            </a:pPr>
+            <a:endParaRPr lang="pt-BR" sz="1200" dirty="0">
+              <a:solidFill>
+                <a:schemeClr val="tx1"/>
+              </a:solidFill>
+              <a:latin typeface="Open Sans" panose="020B0606030504020204" pitchFamily="34" charset="0"/>
+              <a:ea typeface="Open Sans" panose="020B0606030504020204" pitchFamily="34" charset="0"/>
+              <a:cs typeface="Open Sans" panose="020B0606030504020204" pitchFamily="34" charset="0"/>
+            </a:endParaRPr>
+          </a:p>
+          <a:p>
+            <a:pPr lvl="0" algn="just">
+              <a:lnSpc>
+                <a:spcPct val="140000"/>
+              </a:lnSpc>
+            </a:pPr>
+            <a:r>
+              <a:rPr lang="pt-BR" sz="2800" dirty="0">
+                <a:solidFill>
+                  <a:schemeClr val="tx1"/>
+                </a:solidFill>
+                <a:latin typeface="Open Sans" panose="020B0606030504020204" pitchFamily="34" charset="0"/>
+                <a:ea typeface="Open Sans" panose="020B0606030504020204" pitchFamily="34" charset="0"/>
+                <a:cs typeface="Open Sans" panose="020B0606030504020204" pitchFamily="34" charset="0"/>
+              </a:rPr>
+              <a:t>YANG, </a:t>
+            </a:r>
+            <a:r>
+              <a:rPr lang="pt-BR" sz="2800" dirty="0" err="1">
+                <a:solidFill>
+                  <a:schemeClr val="tx1"/>
+                </a:solidFill>
+                <a:latin typeface="Open Sans" panose="020B0606030504020204" pitchFamily="34" charset="0"/>
+                <a:ea typeface="Open Sans" panose="020B0606030504020204" pitchFamily="34" charset="0"/>
+                <a:cs typeface="Open Sans" panose="020B0606030504020204" pitchFamily="34" charset="0"/>
+              </a:rPr>
+              <a:t>Yuanyuan</a:t>
+            </a:r>
+            <a:r>
+              <a:rPr lang="pt-BR" sz="2800" dirty="0">
+                <a:solidFill>
+                  <a:schemeClr val="tx1"/>
+                </a:solidFill>
+                <a:latin typeface="Open Sans" panose="020B0606030504020204" pitchFamily="34" charset="0"/>
+                <a:ea typeface="Open Sans" panose="020B0606030504020204" pitchFamily="34" charset="0"/>
+                <a:cs typeface="Open Sans" panose="020B0606030504020204" pitchFamily="34" charset="0"/>
+              </a:rPr>
+              <a:t>; AN, </a:t>
+            </a:r>
+            <a:r>
+              <a:rPr lang="pt-BR" sz="2800" dirty="0" err="1">
+                <a:solidFill>
+                  <a:schemeClr val="tx1"/>
+                </a:solidFill>
+                <a:latin typeface="Open Sans" panose="020B0606030504020204" pitchFamily="34" charset="0"/>
+                <a:ea typeface="Open Sans" panose="020B0606030504020204" pitchFamily="34" charset="0"/>
+                <a:cs typeface="Open Sans" panose="020B0606030504020204" pitchFamily="34" charset="0"/>
+              </a:rPr>
+              <a:t>Ruopeng</a:t>
+            </a:r>
+            <a:r>
+              <a:rPr lang="pt-BR" sz="2800" dirty="0">
+                <a:solidFill>
+                  <a:schemeClr val="tx1"/>
+                </a:solidFill>
+                <a:latin typeface="Open Sans" panose="020B0606030504020204" pitchFamily="34" charset="0"/>
+                <a:ea typeface="Open Sans" panose="020B0606030504020204" pitchFamily="34" charset="0"/>
+                <a:cs typeface="Open Sans" panose="020B0606030504020204" pitchFamily="34" charset="0"/>
+              </a:rPr>
+              <a:t>; FANG, Cao; FERRIS, Dan. </a:t>
+            </a:r>
+            <a:r>
+              <a:rPr lang="pt-BR" sz="2800" b="1" dirty="0">
+                <a:solidFill>
+                  <a:schemeClr val="tx1"/>
+                </a:solidFill>
+                <a:latin typeface="Open Sans" panose="020B0606030504020204" pitchFamily="34" charset="0"/>
+                <a:ea typeface="Open Sans" panose="020B0606030504020204" pitchFamily="34" charset="0"/>
+                <a:cs typeface="Open Sans" panose="020B0606030504020204" pitchFamily="34" charset="0"/>
+              </a:rPr>
+              <a:t>Artificial </a:t>
+            </a:r>
+            <a:r>
+              <a:rPr lang="pt-BR" sz="2800" b="1" dirty="0" err="1">
+                <a:solidFill>
+                  <a:schemeClr val="tx1"/>
+                </a:solidFill>
+                <a:latin typeface="Open Sans" panose="020B0606030504020204" pitchFamily="34" charset="0"/>
+                <a:ea typeface="Open Sans" panose="020B0606030504020204" pitchFamily="34" charset="0"/>
+                <a:cs typeface="Open Sans" panose="020B0606030504020204" pitchFamily="34" charset="0"/>
+              </a:rPr>
+              <a:t>intelligence</a:t>
+            </a:r>
+            <a:r>
+              <a:rPr lang="pt-BR" sz="2800" b="1" dirty="0">
+                <a:solidFill>
+                  <a:schemeClr val="tx1"/>
+                </a:solidFill>
+                <a:latin typeface="Open Sans" panose="020B0606030504020204" pitchFamily="34" charset="0"/>
+                <a:ea typeface="Open Sans" panose="020B0606030504020204" pitchFamily="34" charset="0"/>
+                <a:cs typeface="Open Sans" panose="020B0606030504020204" pitchFamily="34" charset="0"/>
+              </a:rPr>
+              <a:t> in food bank </a:t>
+            </a:r>
+            <a:r>
+              <a:rPr lang="pt-BR" sz="2800" b="1" dirty="0" err="1">
+                <a:solidFill>
+                  <a:schemeClr val="tx1"/>
+                </a:solidFill>
+                <a:latin typeface="Open Sans" panose="020B0606030504020204" pitchFamily="34" charset="0"/>
+                <a:ea typeface="Open Sans" panose="020B0606030504020204" pitchFamily="34" charset="0"/>
+                <a:cs typeface="Open Sans" panose="020B0606030504020204" pitchFamily="34" charset="0"/>
+              </a:rPr>
+              <a:t>and</a:t>
+            </a:r>
+            <a:r>
+              <a:rPr lang="pt-BR" sz="2800" b="1" dirty="0">
+                <a:solidFill>
+                  <a:schemeClr val="tx1"/>
+                </a:solidFill>
+                <a:latin typeface="Open Sans" panose="020B0606030504020204" pitchFamily="34" charset="0"/>
+                <a:ea typeface="Open Sans" panose="020B0606030504020204" pitchFamily="34" charset="0"/>
+                <a:cs typeface="Open Sans" panose="020B0606030504020204" pitchFamily="34" charset="0"/>
               </a:rPr>
               <a:t> </a:t>
             </a:r>
             <a:r>
-              <a:rPr lang="pt-BR" sz="2800" b="1" noProof="0" dirty="0" err="1">
-                <a:solidFill>
-                  <a:srgbClr val="000000"/>
-                </a:solidFill>
-                <a:latin typeface="Open Sans"/>
-                <a:ea typeface="Open Sans"/>
-                <a:cs typeface="Open Sans"/>
-                <a:sym typeface="Open Sans"/>
+              <a:rPr lang="pt-BR" sz="2800" b="1" dirty="0" err="1">
+                <a:solidFill>
+                  <a:schemeClr val="tx1"/>
+                </a:solidFill>
+                <a:latin typeface="Open Sans" panose="020B0606030504020204" pitchFamily="34" charset="0"/>
+                <a:ea typeface="Open Sans" panose="020B0606030504020204" pitchFamily="34" charset="0"/>
+                <a:cs typeface="Open Sans" panose="020B0606030504020204" pitchFamily="34" charset="0"/>
               </a:rPr>
-              <a:t>to</a:t>
+              <a:t>pantry</a:t>
             </a:r>
             <a:r>
-              <a:rPr lang="pt-BR" sz="2800" b="1" noProof="0" dirty="0">
-                <a:solidFill>
-                  <a:srgbClr val="000000"/>
-                </a:solidFill>
-                <a:latin typeface="Open Sans"/>
-                <a:ea typeface="Open Sans"/>
-                <a:cs typeface="Open Sans"/>
-                <a:sym typeface="Open Sans"/>
+              <a:rPr lang="pt-BR" sz="2800" b="1" dirty="0">
+                <a:solidFill>
+                  <a:schemeClr val="tx1"/>
+                </a:solidFill>
+                <a:latin typeface="Open Sans" panose="020B0606030504020204" pitchFamily="34" charset="0"/>
+                <a:ea typeface="Open Sans" panose="020B0606030504020204" pitchFamily="34" charset="0"/>
+                <a:cs typeface="Open Sans" panose="020B0606030504020204" pitchFamily="34" charset="0"/>
               </a:rPr>
               <a:t> </a:t>
             </a:r>
             <a:r>
-              <a:rPr lang="pt-BR" sz="2800" b="1" noProof="0" dirty="0" err="1">
-                <a:solidFill>
-                  <a:srgbClr val="000000"/>
-                </a:solidFill>
-                <a:latin typeface="Open Sans"/>
-                <a:ea typeface="Open Sans"/>
-                <a:cs typeface="Open Sans"/>
-                <a:sym typeface="Open Sans"/>
+              <a:rPr lang="pt-BR" sz="2800" b="1" dirty="0" err="1">
+                <a:solidFill>
+                  <a:schemeClr val="tx1"/>
+                </a:solidFill>
+                <a:latin typeface="Open Sans" panose="020B0606030504020204" pitchFamily="34" charset="0"/>
+                <a:ea typeface="Open Sans" panose="020B0606030504020204" pitchFamily="34" charset="0"/>
+                <a:cs typeface="Open Sans" panose="020B0606030504020204" pitchFamily="34" charset="0"/>
               </a:rPr>
-              <a:t>Train</a:t>
+              <a:t>services</a:t>
             </a:r>
             <a:r>
-              <a:rPr lang="pt-BR" sz="2800" b="1" noProof="0" dirty="0">
-                <a:solidFill>
-                  <a:srgbClr val="000000"/>
-                </a:solidFill>
-                <a:latin typeface="Open Sans"/>
-                <a:ea typeface="Open Sans"/>
-                <a:cs typeface="Open Sans"/>
-                <a:sym typeface="Open Sans"/>
+              <a:rPr lang="pt-BR" sz="2800" b="1" dirty="0">
+                <a:solidFill>
+                  <a:schemeClr val="tx1"/>
+                </a:solidFill>
+                <a:latin typeface="Open Sans" panose="020B0606030504020204" pitchFamily="34" charset="0"/>
+                <a:ea typeface="Open Sans" panose="020B0606030504020204" pitchFamily="34" charset="0"/>
+                <a:cs typeface="Open Sans" panose="020B0606030504020204" pitchFamily="34" charset="0"/>
               </a:rPr>
-              <a:t> YOLO </a:t>
+              <a:t>: a </a:t>
             </a:r>
             <a:r>
-              <a:rPr lang="pt-BR" sz="2800" b="1" noProof="0" dirty="0" err="1">
-                <a:solidFill>
-                  <a:srgbClr val="000000"/>
-                </a:solidFill>
-                <a:latin typeface="Open Sans"/>
-                <a:ea typeface="Open Sans"/>
-                <a:cs typeface="Open Sans"/>
-                <a:sym typeface="Open Sans"/>
+              <a:rPr lang="pt-BR" sz="2800" b="1" dirty="0" err="1">
+                <a:solidFill>
+                  <a:schemeClr val="tx1"/>
+                </a:solidFill>
+                <a:latin typeface="Open Sans" panose="020B0606030504020204" pitchFamily="34" charset="0"/>
+                <a:ea typeface="Open Sans" panose="020B0606030504020204" pitchFamily="34" charset="0"/>
+                <a:cs typeface="Open Sans" panose="020B0606030504020204" pitchFamily="34" charset="0"/>
               </a:rPr>
-              <a:t>Object</a:t>
+              <a:t>systematic</a:t>
             </a:r>
             <a:r>
-              <a:rPr lang="pt-BR" sz="2800" b="1" noProof="0" dirty="0">
-                <a:solidFill>
-                  <a:srgbClr val="000000"/>
-                </a:solidFill>
-                <a:latin typeface="Open Sans"/>
-                <a:ea typeface="Open Sans"/>
-                <a:cs typeface="Open Sans"/>
-                <a:sym typeface="Open Sans"/>
+              <a:rPr lang="pt-BR" sz="2800" b="1" dirty="0">
+                <a:solidFill>
+                  <a:schemeClr val="tx1"/>
+                </a:solidFill>
+                <a:latin typeface="Open Sans" panose="020B0606030504020204" pitchFamily="34" charset="0"/>
+                <a:ea typeface="Open Sans" panose="020B0606030504020204" pitchFamily="34" charset="0"/>
+                <a:cs typeface="Open Sans" panose="020B0606030504020204" pitchFamily="34" charset="0"/>
               </a:rPr>
-              <a:t> </a:t>
+              <a:t> review</a:t>
             </a:r>
             <a:r>
-              <a:rPr lang="pt-BR" sz="2800" b="1" noProof="0" dirty="0" err="1">
-                <a:solidFill>
-                  <a:srgbClr val="000000"/>
-                </a:solidFill>
-                <a:latin typeface="Open Sans"/>
-                <a:ea typeface="Open Sans"/>
-                <a:cs typeface="Open Sans"/>
-                <a:sym typeface="Open Sans"/>
-              </a:rPr>
-              <a:t>Detection</a:t>
-            </a:r>
-            <a:r>
-              <a:rPr lang="pt-BR" sz="2800" b="1" noProof="0" dirty="0">
-                <a:solidFill>
-                  <a:srgbClr val="000000"/>
-                </a:solidFill>
-                <a:latin typeface="Open Sans"/>
-                <a:ea typeface="Open Sans"/>
-                <a:cs typeface="Open Sans"/>
-                <a:sym typeface="Open Sans"/>
-              </a:rPr>
-              <a:t> Models in Google Colab (YOLO26, YOLO11, YOLOv8). 2025. </a:t>
-            </a:r>
-            <a:r>
-              <a:rPr lang="pt-BR" sz="2800" noProof="0" dirty="0">
-                <a:solidFill>
-                  <a:srgbClr val="000000"/>
-                </a:solidFill>
-                <a:latin typeface="Open Sans"/>
-                <a:ea typeface="Open Sans"/>
-                <a:cs typeface="Open Sans"/>
-                <a:sym typeface="Open Sans"/>
-              </a:rPr>
-              <a:t>Disponível em: https://</a:t>
-            </a:r>
-            <a:r>
-              <a:rPr lang="pt-BR" sz="2800" noProof="0" dirty="0" err="1">
-                <a:solidFill>
-                  <a:srgbClr val="000000"/>
-                </a:solidFill>
-                <a:latin typeface="Open Sans"/>
-                <a:ea typeface="Open Sans"/>
-                <a:cs typeface="Open Sans"/>
-                <a:sym typeface="Open Sans"/>
-              </a:rPr>
-              <a:t>www.youtube.com</a:t>
-            </a:r>
-            <a:r>
-              <a:rPr lang="pt-BR" sz="2800" noProof="0" dirty="0">
-                <a:solidFill>
-                  <a:srgbClr val="000000"/>
-                </a:solidFill>
-                <a:latin typeface="Open Sans"/>
-                <a:ea typeface="Open Sans"/>
-                <a:cs typeface="Open Sans"/>
-                <a:sym typeface="Open Sans"/>
-              </a:rPr>
-              <a:t>/</a:t>
-            </a:r>
-            <a:r>
-              <a:rPr lang="pt-BR" sz="2800" noProof="0" dirty="0" err="1">
-                <a:solidFill>
-                  <a:srgbClr val="000000"/>
-                </a:solidFill>
-                <a:latin typeface="Open Sans"/>
-                <a:ea typeface="Open Sans"/>
-                <a:cs typeface="Open Sans"/>
-                <a:sym typeface="Open Sans"/>
-              </a:rPr>
-              <a:t>watch?v</a:t>
-            </a:r>
-            <a:r>
-              <a:rPr lang="pt-BR" sz="2800" noProof="0" dirty="0">
-                <a:solidFill>
-                  <a:srgbClr val="000000"/>
-                </a:solidFill>
-                <a:latin typeface="Open Sans"/>
-                <a:ea typeface="Open Sans"/>
-                <a:cs typeface="Open Sans"/>
-                <a:sym typeface="Open Sans"/>
-              </a:rPr>
-              <a:t>=r0RspiLG260&amp;t=1091s. Acesso em: 02 abr. 2026.</a:t>
-            </a:r>
-          </a:p>
-          <a:p>
-            <a:pPr marL="0" marR="0" lvl="0" indent="0" algn="just" rtl="0">
-              <a:lnSpc>
-                <a:spcPct val="140000"/>
-              </a:lnSpc>
-              <a:spcBef>
-                <a:spcPts val="0"/>
-              </a:spcBef>
-              <a:spcAft>
-                <a:spcPts val="0"/>
-              </a:spcAft>
-              <a:buNone/>
-            </a:pPr>
-            <a:endParaRPr lang="pt-BR" sz="800" b="1" dirty="0">
-              <a:latin typeface="Open Sans"/>
-              <a:ea typeface="Open Sans"/>
-              <a:cs typeface="Open Sans"/>
-              <a:sym typeface="Open Sans"/>
-            </a:endParaRPr>
-          </a:p>
-          <a:p>
-            <a:pPr marL="0" marR="0" lvl="0" indent="0" algn="just" rtl="0">
-              <a:lnSpc>
-                <a:spcPct val="140000"/>
-              </a:lnSpc>
-              <a:spcBef>
-                <a:spcPts val="0"/>
-              </a:spcBef>
-              <a:spcAft>
-                <a:spcPts val="0"/>
-              </a:spcAft>
-              <a:buNone/>
-            </a:pPr>
-            <a:r>
-              <a:rPr lang="pt-BR" sz="2800" b="1" noProof="0" dirty="0">
-                <a:solidFill>
-                  <a:srgbClr val="000000"/>
-                </a:solidFill>
-                <a:latin typeface="Open Sans"/>
-                <a:ea typeface="Open Sans"/>
-                <a:cs typeface="Open Sans"/>
-                <a:sym typeface="Open Sans"/>
-              </a:rPr>
-              <a:t>LABEL Studio </a:t>
-            </a:r>
-            <a:r>
-              <a:rPr lang="pt-BR" sz="2800" b="1" noProof="0" dirty="0" err="1">
-                <a:solidFill>
-                  <a:srgbClr val="000000"/>
-                </a:solidFill>
-                <a:latin typeface="Open Sans"/>
-                <a:ea typeface="Open Sans"/>
-                <a:cs typeface="Open Sans"/>
-                <a:sym typeface="Open Sans"/>
-              </a:rPr>
-              <a:t>Documentation</a:t>
-            </a:r>
-            <a:r>
-              <a:rPr lang="pt-BR" sz="2800" b="1" noProof="0" dirty="0">
-                <a:solidFill>
-                  <a:srgbClr val="000000"/>
-                </a:solidFill>
-                <a:latin typeface="Open Sans"/>
-                <a:ea typeface="Open Sans"/>
-                <a:cs typeface="Open Sans"/>
-                <a:sym typeface="Open Sans"/>
+              <a:rPr lang="pt-BR" sz="2800" dirty="0">
+                <a:solidFill>
+                  <a:schemeClr val="tx1"/>
+                </a:solidFill>
+                <a:latin typeface="Open Sans" panose="020B0606030504020204" pitchFamily="34" charset="0"/>
+                <a:ea typeface="Open Sans" panose="020B0606030504020204" pitchFamily="34" charset="0"/>
+                <a:cs typeface="Open Sans" panose="020B0606030504020204" pitchFamily="34" charset="0"/>
               </a:rPr>
               <a:t>. </a:t>
             </a:r>
             <a:r>
-              <a:rPr lang="pt-BR" sz="2800" noProof="0" dirty="0">
-                <a:solidFill>
-                  <a:srgbClr val="000000"/>
-                </a:solidFill>
-                <a:latin typeface="Open Sans"/>
-                <a:ea typeface="Open Sans"/>
-                <a:cs typeface="Open Sans"/>
-                <a:sym typeface="Open Sans"/>
+              <a:rPr lang="pt-BR" sz="2800" dirty="0" err="1">
+                <a:solidFill>
+                  <a:schemeClr val="tx1"/>
+                </a:solidFill>
+                <a:latin typeface="Open Sans" panose="020B0606030504020204" pitchFamily="34" charset="0"/>
+                <a:ea typeface="Open Sans" panose="020B0606030504020204" pitchFamily="34" charset="0"/>
+                <a:cs typeface="Open Sans" panose="020B0606030504020204" pitchFamily="34" charset="0"/>
               </a:rPr>
-              <a:t>2026. Disponível em: https://</a:t>
+              <a:t>Nutrients</a:t>
             </a:r>
             <a:r>
-              <a:rPr lang="pt-BR" sz="2800" noProof="0" dirty="0" err="1">
-                <a:solidFill>
-                  <a:srgbClr val="000000"/>
-                </a:solidFill>
-                <a:latin typeface="Open Sans"/>
-                <a:ea typeface="Open Sans"/>
-                <a:cs typeface="Open Sans"/>
-                <a:sym typeface="Open Sans"/>
+              <a:rPr lang="pt-BR" sz="2800" dirty="0">
+                <a:solidFill>
+                  <a:schemeClr val="tx1"/>
+                </a:solidFill>
+                <a:latin typeface="Open Sans" panose="020B0606030504020204" pitchFamily="34" charset="0"/>
+                <a:ea typeface="Open Sans" panose="020B0606030504020204" pitchFamily="34" charset="0"/>
+                <a:cs typeface="Open Sans" panose="020B0606030504020204" pitchFamily="34" charset="0"/>
               </a:rPr>
-              <a:t>labelstud.io</a:t>
+              <a:t>, v. 17, </a:t>
             </a:r>
             <a:r>
-              <a:rPr lang="pt-BR" sz="2800" noProof="0" dirty="0">
-                <a:solidFill>
-                  <a:srgbClr val="000000"/>
-                </a:solidFill>
-                <a:latin typeface="Open Sans"/>
-                <a:ea typeface="Open Sans"/>
-                <a:cs typeface="Open Sans"/>
-                <a:sym typeface="Open Sans"/>
+              <a:rPr lang="pt-BR" sz="2800" dirty="0" err="1">
+                <a:solidFill>
+                  <a:schemeClr val="tx1"/>
+                </a:solidFill>
+                <a:latin typeface="Open Sans" panose="020B0606030504020204" pitchFamily="34" charset="0"/>
+                <a:ea typeface="Open Sans" panose="020B0606030504020204" pitchFamily="34" charset="0"/>
+                <a:cs typeface="Open Sans" panose="020B0606030504020204" pitchFamily="34" charset="0"/>
               </a:rPr>
-              <a:t>/</a:t>
+              <a:t>n</a:t>
             </a:r>
             <a:r>
-              <a:rPr lang="pt-BR" sz="2800" noProof="0" dirty="0" err="1">
-                <a:solidFill>
-                  <a:srgbClr val="000000"/>
-                </a:solidFill>
-                <a:latin typeface="Open Sans"/>
-                <a:ea typeface="Open Sans"/>
-                <a:cs typeface="Open Sans"/>
-                <a:sym typeface="Open Sans"/>
+              <a:rPr lang="pt-BR" sz="2800" dirty="0">
+                <a:solidFill>
+                  <a:schemeClr val="tx1"/>
+                </a:solidFill>
+                <a:latin typeface="Open Sans" panose="020B0606030504020204" pitchFamily="34" charset="0"/>
+                <a:ea typeface="Open Sans" panose="020B0606030504020204" pitchFamily="34" charset="0"/>
+                <a:cs typeface="Open Sans" panose="020B0606030504020204" pitchFamily="34" charset="0"/>
               </a:rPr>
-              <a:t>quick</a:t>
+              <a:t>. 9, p. 1461, 26 abr. 2025. DOI: 10.3390/nu17091461. Disponível em: https://</a:t>
             </a:r>
             <a:r>
-              <a:rPr lang="pt-BR" sz="2800" noProof="0" dirty="0">
-                <a:solidFill>
-                  <a:srgbClr val="000000"/>
-                </a:solidFill>
-                <a:latin typeface="Open Sans"/>
-                <a:ea typeface="Open Sans"/>
-                <a:cs typeface="Open Sans"/>
-                <a:sym typeface="Open Sans"/>
+              <a:rPr lang="pt-BR" sz="2800" dirty="0" err="1">
+                <a:solidFill>
+                  <a:schemeClr val="tx1"/>
+                </a:solidFill>
+                <a:latin typeface="Open Sans" panose="020B0606030504020204" pitchFamily="34" charset="0"/>
+                <a:ea typeface="Open Sans" panose="020B0606030504020204" pitchFamily="34" charset="0"/>
+                <a:cs typeface="Open Sans" panose="020B0606030504020204" pitchFamily="34" charset="0"/>
               </a:rPr>
-              <a:t>-start/. Acesso em: 02 abr. 2026.</a:t>
+              <a:t>www.mdpi.com</a:t>
             </a:r>
-          </a:p>
-          <a:p>
-            <a:pPr marL="0" marR="0" lvl="0" indent="0" algn="just" rtl="0">
-              <a:lnSpc>
-                <a:spcPct val="140000"/>
-              </a:lnSpc>
-              <a:spcBef>
-                <a:spcPts val="0"/>
-              </a:spcBef>
-              <a:spcAft>
-                <a:spcPts val="0"/>
-              </a:spcAft>
-              <a:buNone/>
-            </a:pPr>
-            <a:endParaRPr lang="pt-BR" sz="800" dirty="0">
-              <a:latin typeface="Open Sans"/>
-              <a:ea typeface="Open Sans"/>
-              <a:cs typeface="Open Sans"/>
+            <a:r>
+              <a:rPr lang="pt-BR" sz="2800" dirty="0">
+                <a:solidFill>
+                  <a:schemeClr val="tx1"/>
+                </a:solidFill>
+                <a:latin typeface="Open Sans" panose="020B0606030504020204" pitchFamily="34" charset="0"/>
+                <a:ea typeface="Open Sans" panose="020B0606030504020204" pitchFamily="34" charset="0"/>
+                <a:cs typeface="Open Sans" panose="020B0606030504020204" pitchFamily="34" charset="0"/>
+              </a:rPr>
+              <a:t>/2072-6643/17/9/1461. Acesso em: 15 fev. 2026.</a:t>
+            </a:r>
+            <a:endParaRPr lang="pt-BR" sz="2800" noProof="0" dirty="0">
+              <a:solidFill>
+                <a:schemeClr val="tx1"/>
+              </a:solidFill>
+              <a:latin typeface="Open Sans" panose="020B0606030504020204" pitchFamily="34" charset="0"/>
+              <a:ea typeface="Open Sans" panose="020B0606030504020204" pitchFamily="34" charset="0"/>
+              <a:cs typeface="Open Sans" panose="020B0606030504020204" pitchFamily="34" charset="0"/>
               <a:sym typeface="Open Sans"/>
             </a:endParaRPr>
-          </a:p>
-          <a:p>
-            <a:pPr marL="0" marR="0" lvl="0" indent="0" algn="just" rtl="0">
-              <a:lnSpc>
-                <a:spcPct val="140000"/>
-              </a:lnSpc>
-              <a:spcBef>
-                <a:spcPts val="0"/>
-              </a:spcBef>
-              <a:spcAft>
-                <a:spcPts val="0"/>
-              </a:spcAft>
-              <a:buNone/>
-            </a:pPr>
-            <a:r>
-              <a:rPr lang="pt-BR" sz="2800" noProof="0" dirty="0">
-                <a:solidFill>
-                  <a:srgbClr val="000000"/>
-                </a:solidFill>
-                <a:latin typeface="Open Sans"/>
-                <a:ea typeface="Open Sans"/>
-                <a:cs typeface="Open Sans"/>
-                <a:sym typeface="Open Sans"/>
-              </a:rPr>
-              <a:t>TEIMOURPOUR, </a:t>
-            </a:r>
-            <a:r>
-              <a:rPr lang="pt-BR" sz="2800" noProof="0" dirty="0" err="1">
-                <a:solidFill>
-                  <a:srgbClr val="000000"/>
-                </a:solidFill>
-                <a:latin typeface="Open Sans"/>
-                <a:ea typeface="Open Sans"/>
-                <a:cs typeface="Open Sans"/>
-                <a:sym typeface="Open Sans"/>
-              </a:rPr>
-              <a:t>Babak</a:t>
-            </a:r>
-            <a:r>
-              <a:rPr lang="pt-BR" sz="2800" noProof="0" dirty="0">
-                <a:solidFill>
-                  <a:srgbClr val="000000"/>
-                </a:solidFill>
-                <a:latin typeface="Open Sans"/>
-                <a:ea typeface="Open Sans"/>
-                <a:cs typeface="Open Sans"/>
-                <a:sym typeface="Open Sans"/>
-              </a:rPr>
-              <a:t>. </a:t>
-            </a:r>
-            <a:r>
-              <a:rPr lang="pt-BR" sz="2800" b="1" noProof="0" dirty="0">
-                <a:solidFill>
-                  <a:srgbClr val="000000"/>
-                </a:solidFill>
-                <a:latin typeface="Open Sans"/>
-                <a:ea typeface="Open Sans"/>
-                <a:cs typeface="Open Sans"/>
-                <a:sym typeface="Open Sans"/>
-              </a:rPr>
-              <a:t>Computer Vision in </a:t>
-            </a:r>
-            <a:r>
-              <a:rPr lang="pt-BR" sz="2800" b="1" noProof="0" dirty="0" err="1">
-                <a:solidFill>
-                  <a:srgbClr val="000000"/>
-                </a:solidFill>
-                <a:latin typeface="Open Sans"/>
-                <a:ea typeface="Open Sans"/>
-                <a:cs typeface="Open Sans"/>
-                <a:sym typeface="Open Sans"/>
-              </a:rPr>
-              <a:t>the</a:t>
-            </a:r>
-            <a:r>
-              <a:rPr lang="pt-BR" sz="2800" b="1" noProof="0" dirty="0">
-                <a:solidFill>
-                  <a:srgbClr val="000000"/>
-                </a:solidFill>
-                <a:latin typeface="Open Sans"/>
-                <a:ea typeface="Open Sans"/>
-                <a:cs typeface="Open Sans"/>
-                <a:sym typeface="Open Sans"/>
-              </a:rPr>
-              <a:t> Food </a:t>
-            </a:r>
-            <a:r>
-              <a:rPr lang="pt-BR" sz="2800" b="1" noProof="0" dirty="0" err="1">
-                <a:solidFill>
-                  <a:srgbClr val="000000"/>
-                </a:solidFill>
-                <a:latin typeface="Open Sans"/>
-                <a:ea typeface="Open Sans"/>
-                <a:cs typeface="Open Sans"/>
-                <a:sym typeface="Open Sans"/>
-              </a:rPr>
-              <a:t>Industry</a:t>
-            </a:r>
-            <a:r>
-              <a:rPr lang="pt-BR" sz="2800" b="1" noProof="0" dirty="0">
-                <a:solidFill>
-                  <a:srgbClr val="000000"/>
-                </a:solidFill>
-                <a:latin typeface="Open Sans"/>
-                <a:ea typeface="Open Sans"/>
-                <a:cs typeface="Open Sans"/>
-                <a:sym typeface="Open Sans"/>
-              </a:rPr>
-              <a:t>: </a:t>
-            </a:r>
-            <a:r>
-              <a:rPr lang="pt-BR" sz="2800" b="1" noProof="0" dirty="0" err="1">
-                <a:solidFill>
-                  <a:srgbClr val="000000"/>
-                </a:solidFill>
-                <a:latin typeface="Open Sans"/>
-                <a:ea typeface="Open Sans"/>
-                <a:cs typeface="Open Sans"/>
-                <a:sym typeface="Open Sans"/>
-              </a:rPr>
-              <a:t>Accurate</a:t>
-            </a:r>
-            <a:r>
-              <a:rPr lang="pt-BR" sz="2800" b="1" noProof="0" dirty="0">
-                <a:solidFill>
-                  <a:srgbClr val="000000"/>
-                </a:solidFill>
-                <a:latin typeface="Open Sans"/>
-                <a:ea typeface="Open Sans"/>
-                <a:cs typeface="Open Sans"/>
-                <a:sym typeface="Open Sans"/>
-              </a:rPr>
-              <a:t>, Real-time, </a:t>
-            </a:r>
-            <a:r>
-              <a:rPr lang="pt-BR" sz="2800" b="1" noProof="0" dirty="0" err="1">
-                <a:solidFill>
-                  <a:srgbClr val="000000"/>
-                </a:solidFill>
-                <a:latin typeface="Open Sans"/>
-                <a:ea typeface="Open Sans"/>
-                <a:cs typeface="Open Sans"/>
-                <a:sym typeface="Open Sans"/>
-              </a:rPr>
-              <a:t>and</a:t>
-            </a:r>
-            <a:r>
-              <a:rPr lang="pt-BR" sz="2800" b="1" noProof="0" dirty="0">
-                <a:solidFill>
-                  <a:srgbClr val="000000"/>
-                </a:solidFill>
-                <a:latin typeface="Open Sans"/>
-                <a:ea typeface="Open Sans"/>
-                <a:cs typeface="Open Sans"/>
-                <a:sym typeface="Open Sans"/>
-              </a:rPr>
-              <a:t> </a:t>
-            </a:r>
-            <a:r>
-              <a:rPr lang="pt-BR" sz="2800" b="1" noProof="0" dirty="0" err="1">
-                <a:solidFill>
-                  <a:srgbClr val="000000"/>
-                </a:solidFill>
-                <a:latin typeface="Open Sans"/>
-                <a:ea typeface="Open Sans"/>
-                <a:cs typeface="Open Sans"/>
-                <a:sym typeface="Open Sans"/>
-              </a:rPr>
-              <a:t>Automatic</a:t>
-            </a:r>
-            <a:r>
-              <a:rPr lang="pt-BR" sz="2800" b="1" noProof="0" dirty="0">
-                <a:solidFill>
-                  <a:srgbClr val="000000"/>
-                </a:solidFill>
-                <a:latin typeface="Open Sans"/>
-                <a:ea typeface="Open Sans"/>
-                <a:cs typeface="Open Sans"/>
-                <a:sym typeface="Open Sans"/>
-              </a:rPr>
-              <a:t> Food </a:t>
-            </a:r>
-            <a:r>
-              <a:rPr lang="pt-BR" sz="2800" b="1" noProof="0" dirty="0" err="1">
-                <a:solidFill>
-                  <a:srgbClr val="000000"/>
-                </a:solidFill>
-                <a:latin typeface="Open Sans"/>
-                <a:ea typeface="Open Sans"/>
-                <a:cs typeface="Open Sans"/>
-                <a:sym typeface="Open Sans"/>
-              </a:rPr>
-              <a:t>Recognition</a:t>
-            </a:r>
-            <a:r>
-              <a:rPr lang="pt-BR" sz="2800" b="1" noProof="0" dirty="0">
-                <a:solidFill>
-                  <a:srgbClr val="000000"/>
-                </a:solidFill>
-                <a:latin typeface="Open Sans"/>
-                <a:ea typeface="Open Sans"/>
-                <a:cs typeface="Open Sans"/>
-                <a:sym typeface="Open Sans"/>
-              </a:rPr>
-              <a:t> </a:t>
-            </a:r>
-            <a:r>
-              <a:rPr lang="pt-BR" sz="2800" b="1" noProof="0" dirty="0" err="1">
-                <a:solidFill>
-                  <a:srgbClr val="000000"/>
-                </a:solidFill>
-                <a:latin typeface="Open Sans"/>
-                <a:ea typeface="Open Sans"/>
-                <a:cs typeface="Open Sans"/>
-                <a:sym typeface="Open Sans"/>
-              </a:rPr>
-              <a:t>with</a:t>
-            </a:r>
-            <a:r>
-              <a:rPr lang="pt-BR" sz="2800" b="1" noProof="0" dirty="0">
-                <a:solidFill>
-                  <a:srgbClr val="000000"/>
-                </a:solidFill>
-                <a:latin typeface="Open Sans"/>
-                <a:ea typeface="Open Sans"/>
-                <a:cs typeface="Open Sans"/>
-                <a:sym typeface="Open Sans"/>
-              </a:rPr>
-              <a:t> </a:t>
-            </a:r>
-            <a:r>
-              <a:rPr lang="pt-BR" sz="2800" b="1" noProof="0" dirty="0" err="1">
-                <a:solidFill>
-                  <a:srgbClr val="000000"/>
-                </a:solidFill>
-                <a:latin typeface="Open Sans"/>
-                <a:ea typeface="Open Sans"/>
-                <a:cs typeface="Open Sans"/>
-                <a:sym typeface="Open Sans"/>
-              </a:rPr>
-              <a:t>Pretrained</a:t>
-            </a:r>
-            <a:r>
-              <a:rPr lang="pt-BR" sz="2800" b="1" noProof="0" dirty="0">
-                <a:solidFill>
-                  <a:srgbClr val="000000"/>
-                </a:solidFill>
-                <a:latin typeface="Open Sans"/>
-                <a:ea typeface="Open Sans"/>
-                <a:cs typeface="Open Sans"/>
-                <a:sym typeface="Open Sans"/>
-              </a:rPr>
-              <a:t> MobileNetV2. </a:t>
-            </a:r>
-            <a:r>
-              <a:rPr lang="pt-BR" sz="2800" noProof="0" dirty="0">
-                <a:solidFill>
-                  <a:srgbClr val="000000"/>
-                </a:solidFill>
-                <a:latin typeface="Open Sans"/>
-                <a:ea typeface="Open Sans"/>
-                <a:cs typeface="Open Sans"/>
-                <a:sym typeface="Open Sans"/>
-              </a:rPr>
-              <a:t>2024. Disponível em: https://</a:t>
-            </a:r>
-            <a:r>
-              <a:rPr lang="pt-BR" sz="2800" noProof="0" dirty="0" err="1">
-                <a:solidFill>
-                  <a:srgbClr val="000000"/>
-                </a:solidFill>
-                <a:latin typeface="Open Sans"/>
-                <a:ea typeface="Open Sans"/>
-                <a:cs typeface="Open Sans"/>
-                <a:sym typeface="Open Sans"/>
-              </a:rPr>
-              <a:t>arxiv.org</a:t>
-            </a:r>
-            <a:r>
-              <a:rPr lang="pt-BR" sz="2800" noProof="0" dirty="0">
-                <a:solidFill>
-                  <a:srgbClr val="000000"/>
-                </a:solidFill>
-                <a:latin typeface="Open Sans"/>
-                <a:ea typeface="Open Sans"/>
-                <a:cs typeface="Open Sans"/>
-                <a:sym typeface="Open Sans"/>
-              </a:rPr>
-              <a:t>/</a:t>
-            </a:r>
-            <a:r>
-              <a:rPr lang="pt-BR" sz="2800" noProof="0" dirty="0" err="1">
-                <a:solidFill>
-                  <a:srgbClr val="000000"/>
-                </a:solidFill>
-                <a:latin typeface="Open Sans"/>
-                <a:ea typeface="Open Sans"/>
-                <a:cs typeface="Open Sans"/>
-                <a:sym typeface="Open Sans"/>
-              </a:rPr>
-              <a:t>abs</a:t>
-            </a:r>
-            <a:r>
-              <a:rPr lang="pt-BR" sz="2800" noProof="0" dirty="0">
-                <a:solidFill>
-                  <a:srgbClr val="000000"/>
-                </a:solidFill>
-                <a:latin typeface="Open Sans"/>
-                <a:ea typeface="Open Sans"/>
-                <a:cs typeface="Open Sans"/>
-                <a:sym typeface="Open Sans"/>
-              </a:rPr>
-              <a:t>/2405.11621. Acesso em: 15 fev. 2026.</a:t>
-            </a:r>
           </a:p>
         </p:txBody>
       </p:sp>
@@ -15409,7 +15386,7 @@
         </p:blipFill>
         <p:spPr bwMode="auto">
           <a:xfrm>
-            <a:off x="12213289" y="36794665"/>
+            <a:off x="11854370" y="36815167"/>
             <a:ext cx="1234800" cy="1234800"/>
           </a:xfrm>
           <a:prstGeom prst="rect">

</xml_diff>